<commit_message>
Fix terminal text overflow on key slides
Reduced terminal content density on slides 3 (tmux mockup),
7 (gstack install), 20 (ship pipeline), and 24 (investigate)
to prevent text clipping and improve readability.

Co-Authored-By: Claude Opus 4.6 <noreply@anthropic.com>
</commit_message>
<xml_diff>
--- a/ai-dev-talk.pptx
+++ b/ai-dev-talk.pptx
@@ -15797,7 +15797,7 @@
                 </a:solidFill>
                 <a:latin typeface="Consolas"/>
               </a:rPr>
-              <a:t>  ● Running test suite...</a:t>
+              <a:t>  ● Running tests...</a:t>
             </a:r>
           </a:p>
           <a:p>
@@ -15816,7 +15816,7 @@
                 </a:solidFill>
                 <a:latin typeface="Consolas"/>
               </a:rPr>
-              <a:t>    ✓ 92 tests passed (0 failed, 0 skipped)</a:t>
+              <a:t>    ✓ 92 tests passed</a:t>
             </a:r>
           </a:p>
           <a:p>
@@ -15873,7 +15873,7 @@
                 </a:solidFill>
                 <a:latin typeface="Consolas"/>
               </a:rPr>
-              <a:t>    + Added TikTok integration (Broadside)</a:t>
+              <a:t>    + TikTok integration (Broadside)</a:t>
             </a:r>
           </a:p>
           <a:p>
@@ -15892,7 +15892,7 @@
                 </a:solidFill>
                 <a:latin typeface="Consolas"/>
               </a:rPr>
-              <a:t>    + Fixed token refresh bug (Cortis)</a:t>
+              <a:t>    + Token refresh fix (Cortis)</a:t>
             </a:r>
           </a:p>
           <a:p>
@@ -15907,11 +15907,30 @@
             <a:r>
               <a:rPr sz="1200">
                 <a:solidFill>
+                  <a:srgbClr val="CDD6F4"/>
+                </a:solidFill>
+                <a:latin typeface="Consolas"/>
+              </a:rPr>
+              <a:t/>
+            </a:r>
+          </a:p>
+          <a:p>
+            <a:pPr>
+              <a:spcBef>
+                <a:spcPts val="200"/>
+              </a:spcBef>
+              <a:spcAft>
+                <a:spcPts val="0"/>
+              </a:spcAft>
+            </a:pPr>
+            <a:r>
+              <a:rPr sz="1200">
+                <a:solidFill>
                   <a:srgbClr val="A6ADC8"/>
                 </a:solidFill>
                 <a:latin typeface="Consolas"/>
               </a:rPr>
-              <a:t>    + New Python challenge: async/await (Zeroshot)</a:t>
+              <a:t>  ● Bumping version...</a:t>
             </a:r>
           </a:p>
           <a:p>
@@ -15926,6 +15945,25 @@
             <a:r>
               <a:rPr sz="1200">
                 <a:solidFill>
+                  <a:srgbClr val="89B4FA"/>
+                </a:solidFill>
+                <a:latin typeface="Consolas"/>
+              </a:rPr>
+              <a:t>    1.4.2 → 1.5.0</a:t>
+            </a:r>
+          </a:p>
+          <a:p>
+            <a:pPr>
+              <a:spcBef>
+                <a:spcPts val="200"/>
+              </a:spcBef>
+              <a:spcAft>
+                <a:spcPts val="0"/>
+              </a:spcAft>
+            </a:pPr>
+            <a:r>
+              <a:rPr sz="1200">
+                <a:solidFill>
                   <a:srgbClr val="CDD6F4"/>
                 </a:solidFill>
                 <a:latin typeface="Consolas"/>
@@ -15949,7 +15987,7 @@
                 </a:solidFill>
                 <a:latin typeface="Consolas"/>
               </a:rPr>
-              <a:t>  ● Bumping version...</a:t>
+              <a:t>  ● Creating pull request...</a:t>
             </a:r>
           </a:p>
           <a:p>
@@ -15968,7 +16006,7 @@
                 </a:solidFill>
                 <a:latin typeface="Consolas"/>
               </a:rPr>
-              <a:t>    1.4.2 → 1.5.0 (minor: new feature)</a:t>
+              <a:t>    → PR #48: feat: TikTok support</a:t>
             </a:r>
           </a:p>
           <a:p>
@@ -16002,87 +16040,11 @@
             <a:r>
               <a:rPr sz="1200">
                 <a:solidFill>
-                  <a:srgbClr val="A6ADC8"/>
+                  <a:srgbClr val="A6E3A1"/>
                 </a:solidFill>
                 <a:latin typeface="Consolas"/>
               </a:rPr>
-              <a:t>  ● Creating pull request...</a:t>
-            </a:r>
-          </a:p>
-          <a:p>
-            <a:pPr>
-              <a:spcBef>
-                <a:spcPts val="200"/>
-              </a:spcBef>
-              <a:spcAft>
-                <a:spcPts val="0"/>
-              </a:spcAft>
-            </a:pPr>
-            <a:r>
-              <a:rPr sz="1200">
-                <a:solidFill>
-                  <a:srgbClr val="89B4FA"/>
-                </a:solidFill>
-                <a:latin typeface="Consolas"/>
-              </a:rPr>
-              <a:t>    → PR #48: feat: TikTok posting support</a:t>
-            </a:r>
-          </a:p>
-          <a:p>
-            <a:pPr>
-              <a:spcBef>
-                <a:spcPts val="200"/>
-              </a:spcBef>
-              <a:spcAft>
-                <a:spcPts val="0"/>
-              </a:spcAft>
-            </a:pPr>
-            <a:r>
-              <a:rPr sz="1200">
-                <a:solidFill>
-                  <a:srgbClr val="89B4FA"/>
-                </a:solidFill>
-                <a:latin typeface="Consolas"/>
-              </a:rPr>
-              <a:t>    → 3 reviewers assigned</a:t>
-            </a:r>
-          </a:p>
-          <a:p>
-            <a:pPr>
-              <a:spcBef>
-                <a:spcPts val="200"/>
-              </a:spcBef>
-              <a:spcAft>
-                <a:spcPts val="0"/>
-              </a:spcAft>
-            </a:pPr>
-            <a:r>
-              <a:rPr sz="1200">
-                <a:solidFill>
-                  <a:srgbClr val="CDD6F4"/>
-                </a:solidFill>
-                <a:latin typeface="Consolas"/>
-              </a:rPr>
-              <a:t/>
-            </a:r>
-          </a:p>
-          <a:p>
-            <a:pPr>
-              <a:spcBef>
-                <a:spcPts val="200"/>
-              </a:spcBef>
-              <a:spcAft>
-                <a:spcPts val="0"/>
-              </a:spcAft>
-            </a:pPr>
-            <a:r>
-              <a:rPr sz="1200">
-                <a:solidFill>
-                  <a:srgbClr val="A6E3A1"/>
-                </a:solidFill>
-                <a:latin typeface="Consolas"/>
-              </a:rPr>
-              <a:t>  ✓ Ship complete. PR ready for review.</a:t>
+              <a:t>  ✓ Ship complete. PR ready.</a:t>
             </a:r>
           </a:p>
         </p:txBody>
@@ -17699,7 +17661,7 @@
         <p:spPr>
           <a:xfrm>
             <a:off x="457200" y="1371600"/>
-            <a:ext cx="11247120" cy="5029200"/>
+            <a:ext cx="11247120" cy="4754880"/>
           </a:xfrm>
           <a:prstGeom prst="roundRect">
             <a:avLst/>
@@ -17956,7 +17918,7 @@
         <p:spPr>
           <a:xfrm>
             <a:off x="685800" y="1828800"/>
-            <a:ext cx="10789920" cy="4480560"/>
+            <a:ext cx="10789920" cy="4206240"/>
           </a:xfrm>
           <a:prstGeom prst="rect">
             <a:avLst/>
@@ -18041,7 +18003,7 @@
                 </a:solidFill>
                 <a:latin typeface="Consolas"/>
               </a:rPr>
-              <a:t>    TypeError in /api/meetings/enrich line 47</a:t>
+              <a:t>    TypeError in /api/meetings/enrich:47</a:t>
             </a:r>
           </a:p>
           <a:p>
@@ -18098,7 +18060,7 @@
                 </a:solidFill>
                 <a:latin typeface="Consolas"/>
               </a:rPr>
-              <a:t>    enrich() → fetch_participant() → pinecone.query()</a:t>
+              <a:t>    enrich() → fetch_participant()</a:t>
             </a:r>
           </a:p>
           <a:p>
@@ -18117,7 +18079,7 @@
                 </a:solidFill>
                 <a:latin typeface="Consolas"/>
               </a:rPr>
-              <a:t>    → Pinecone client timeout (connection pool exhausted)</a:t>
+              <a:t>    → Pinecone timeout (pool exhausted)</a:t>
             </a:r>
           </a:p>
           <a:p>
@@ -18170,11 +18132,49 @@
             <a:r>
               <a:rPr sz="1200">
                 <a:solidFill>
+                  <a:srgbClr val="89B4FA"/>
+                </a:solidFill>
+                <a:latin typeface="Consolas"/>
+              </a:rPr>
+              <a:t>    PR #44 (3 days ago): pool 10 → 5</a:t>
+            </a:r>
+          </a:p>
+          <a:p>
+            <a:pPr>
+              <a:spcBef>
+                <a:spcPts val="200"/>
+              </a:spcBef>
+              <a:spcAft>
+                <a:spcPts val="0"/>
+              </a:spcAft>
+            </a:pPr>
+            <a:r>
+              <a:rPr sz="1200">
+                <a:solidFill>
+                  <a:srgbClr val="CDD6F4"/>
+                </a:solidFill>
+                <a:latin typeface="Consolas"/>
+              </a:rPr>
+              <a:t/>
+            </a:r>
+          </a:p>
+          <a:p>
+            <a:pPr>
+              <a:spcBef>
+                <a:spcPts val="200"/>
+              </a:spcBef>
+              <a:spcAft>
+                <a:spcPts val="0"/>
+              </a:spcAft>
+            </a:pPr>
+            <a:r>
+              <a:rPr sz="1200">
+                <a:solidFill>
                   <a:srgbClr val="A6ADC8"/>
                 </a:solidFill>
                 <a:latin typeface="Consolas"/>
               </a:rPr>
-              <a:t>    Last change: 3 days ago — PR #44 (batch enrichment)</a:t>
+              <a:t>  ● Auto-freeze: /api/meetings/</a:t>
             </a:r>
           </a:p>
           <a:p>
@@ -18189,11 +18189,49 @@
             <a:r>
               <a:rPr sz="1200">
                 <a:solidFill>
+                  <a:srgbClr val="CDD6F4"/>
+                </a:solidFill>
+                <a:latin typeface="Consolas"/>
+              </a:rPr>
+              <a:t/>
+            </a:r>
+          </a:p>
+          <a:p>
+            <a:pPr>
+              <a:spcBef>
+                <a:spcPts val="200"/>
+              </a:spcBef>
+              <a:spcAft>
+                <a:spcPts val="0"/>
+              </a:spcAft>
+            </a:pPr>
+            <a:r>
+              <a:rPr sz="1200">
+                <a:solidFill>
+                  <a:srgbClr val="A6ADC8"/>
+                </a:solidFill>
+                <a:latin typeface="Consolas"/>
+              </a:rPr>
+              <a:t>  ● Root cause: Pool too small (92%)</a:t>
+            </a:r>
+          </a:p>
+          <a:p>
+            <a:pPr>
+              <a:spcBef>
+                <a:spcPts val="200"/>
+              </a:spcBef>
+              <a:spcAft>
+                <a:spcPts val="0"/>
+              </a:spcAft>
+            </a:pPr>
+            <a:r>
+              <a:rPr sz="1200">
+                <a:solidFill>
                   <a:srgbClr val="89B4FA"/>
                 </a:solidFill>
                 <a:latin typeface="Consolas"/>
               </a:rPr>
-              <a:t>    Changed: connection pool size 10 → 5 (optimization attempt)</a:t>
+              <a:t>  → Fix: Revert pool, add backpressure</a:t>
             </a:r>
           </a:p>
           <a:p>
@@ -18208,163 +18246,11 @@
             <a:r>
               <a:rPr sz="1200">
                 <a:solidFill>
-                  <a:srgbClr val="CDD6F4"/>
+                  <a:srgbClr val="89B4FA"/>
                 </a:solidFill>
                 <a:latin typeface="Consolas"/>
               </a:rPr>
-              <a:t/>
-            </a:r>
-          </a:p>
-          <a:p>
-            <a:pPr>
-              <a:spcBef>
-                <a:spcPts val="200"/>
-              </a:spcBef>
-              <a:spcAft>
-                <a:spcPts val="0"/>
-              </a:spcAft>
-            </a:pPr>
-            <a:r>
-              <a:rPr sz="1200">
-                <a:solidFill>
-                  <a:srgbClr val="A6ADC8"/>
-                </a:solidFill>
-                <a:latin typeface="Consolas"/>
-              </a:rPr>
-              <a:t>  ● Auto-freezing to affected module...</a:t>
-            </a:r>
-          </a:p>
-          <a:p>
-            <a:pPr>
-              <a:spcBef>
-                <a:spcPts val="200"/>
-              </a:spcBef>
-              <a:spcAft>
-                <a:spcPts val="0"/>
-              </a:spcAft>
-            </a:pPr>
-            <a:r>
-              <a:rPr sz="1200">
-                <a:solidFill>
-                  <a:srgbClr val="A6E3A1"/>
-                </a:solidFill>
-                <a:latin typeface="Consolas"/>
-              </a:rPr>
-              <a:t>    ✓ Locked to /api/meetings/</a:t>
-            </a:r>
-          </a:p>
-          <a:p>
-            <a:pPr>
-              <a:spcBef>
-                <a:spcPts val="200"/>
-              </a:spcBef>
-              <a:spcAft>
-                <a:spcPts val="0"/>
-              </a:spcAft>
-            </a:pPr>
-            <a:r>
-              <a:rPr sz="1200">
-                <a:solidFill>
-                  <a:srgbClr val="CDD6F4"/>
-                </a:solidFill>
-                <a:latin typeface="Consolas"/>
-              </a:rPr>
-              <a:t/>
-            </a:r>
-          </a:p>
-          <a:p>
-            <a:pPr>
-              <a:spcBef>
-                <a:spcPts val="200"/>
-              </a:spcBef>
-              <a:spcAft>
-                <a:spcPts val="0"/>
-              </a:spcAft>
-            </a:pPr>
-            <a:r>
-              <a:rPr sz="1200">
-                <a:solidFill>
-                  <a:srgbClr val="A6ADC8"/>
-                </a:solidFill>
-                <a:latin typeface="Consolas"/>
-              </a:rPr>
-              <a:t>  ● Root cause: Connection pool too small for batch load</a:t>
-            </a:r>
-          </a:p>
-          <a:p>
-            <a:pPr>
-              <a:spcBef>
-                <a:spcPts val="200"/>
-              </a:spcBef>
-              <a:spcAft>
-                <a:spcPts val="0"/>
-              </a:spcAft>
-            </a:pPr>
-            <a:r>
-              <a:rPr sz="1200">
-                <a:solidFill>
-                  <a:srgbClr val="A6ADC8"/>
-                </a:solidFill>
-                <a:latin typeface="Consolas"/>
-              </a:rPr>
-              <a:t>    Confidence: HIGH (92%)</a:t>
-            </a:r>
-          </a:p>
-          <a:p>
-            <a:pPr>
-              <a:spcBef>
-                <a:spcPts val="200"/>
-              </a:spcBef>
-              <a:spcAft>
-                <a:spcPts val="0"/>
-              </a:spcAft>
-            </a:pPr>
-            <a:r>
-              <a:rPr sz="1200">
-                <a:solidFill>
-                  <a:srgbClr val="CDD6F4"/>
-                </a:solidFill>
-                <a:latin typeface="Consolas"/>
-              </a:rPr>
-              <a:t/>
-            </a:r>
-          </a:p>
-          <a:p>
-            <a:pPr>
-              <a:spcBef>
-                <a:spcPts val="200"/>
-              </a:spcBef>
-              <a:spcAft>
-                <a:spcPts val="0"/>
-              </a:spcAft>
-            </a:pPr>
-            <a:r>
-              <a:rPr sz="1200">
-                <a:solidFill>
-                  <a:srgbClr val="89B4FA"/>
-                </a:solidFill>
-                <a:latin typeface="Consolas"/>
-              </a:rPr>
-              <a:t>  → Suggested fix: Revert pool size to 10, add backpressure</a:t>
-            </a:r>
-          </a:p>
-          <a:p>
-            <a:pPr>
-              <a:spcBef>
-                <a:spcPts val="200"/>
-              </a:spcBef>
-              <a:spcAft>
-                <a:spcPts val="0"/>
-              </a:spcAft>
-            </a:pPr>
-            <a:r>
-              <a:rPr sz="1200">
-                <a:solidFill>
-                  <a:srgbClr val="89B4FA"/>
-                </a:solidFill>
-                <a:latin typeface="Consolas"/>
-              </a:rPr>
-              <a:t>  → Rollback plan: git revert PR #44</a:t>
+              <a:t>  → Rollback: git revert PR #44</a:t>
             </a:r>
           </a:p>
         </p:txBody>
@@ -21325,7 +21211,7 @@
         <p:spPr>
           <a:xfrm>
             <a:off x="457200" y="1188720"/>
-            <a:ext cx="3566160" cy="2560320"/>
+            <a:ext cx="3566160" cy="2377440"/>
           </a:xfrm>
           <a:prstGeom prst="roundRect">
             <a:avLst/>
@@ -21582,7 +21468,7 @@
         <p:spPr>
           <a:xfrm>
             <a:off x="685800" y="1645920"/>
-            <a:ext cx="3108960" cy="2011679"/>
+            <a:ext cx="3108960" cy="1828800"/>
           </a:xfrm>
           <a:prstGeom prst="rect">
             <a:avLst/>
@@ -21629,7 +21515,7 @@
                 </a:solidFill>
                 <a:latin typeface="Consolas"/>
               </a:rPr>
-              <a:t>  Found potential token refresh issue</a:t>
+              <a:t>  Found token refresh issue</a:t>
             </a:r>
           </a:p>
           <a:p>
@@ -21648,7 +21534,7 @@
                 </a:solidFill>
                 <a:latin typeface="Consolas"/>
               </a:rPr>
-              <a:t>  → Proposing fix in auth/refresh.ts</a:t>
+              <a:t>  → Fix in auth/refresh.ts</a:t>
             </a:r>
           </a:p>
           <a:p>
@@ -21681,7 +21567,7 @@
         <p:spPr>
           <a:xfrm>
             <a:off x="4206240" y="1188720"/>
-            <a:ext cx="3566160" cy="2560320"/>
+            <a:ext cx="3566160" cy="2377440"/>
           </a:xfrm>
           <a:prstGeom prst="roundRect">
             <a:avLst/>
@@ -21938,7 +21824,7 @@
         <p:spPr>
           <a:xfrm>
             <a:off x="4434840" y="1645920"/>
-            <a:ext cx="3108960" cy="2011679"/>
+            <a:ext cx="3108960" cy="1828800"/>
           </a:xfrm>
           <a:prstGeom prst="rect">
             <a:avLst/>
@@ -21966,7 +21852,7 @@
                 </a:solidFill>
                 <a:latin typeface="Consolas"/>
               </a:rPr>
-              <a:t>❯ Adding TikTok integration...</a:t>
+              <a:t>❯ Adding TikTok integration</a:t>
             </a:r>
           </a:p>
           <a:p>
@@ -21985,7 +21871,7 @@
                 </a:solidFill>
                 <a:latin typeface="Consolas"/>
               </a:rPr>
-              <a:t>  Reading TikTok API docs...</a:t>
+              <a:t>  Reading TikTok API docs</a:t>
             </a:r>
           </a:p>
           <a:p>
@@ -22037,7 +21923,7 @@
         <p:spPr>
           <a:xfrm>
             <a:off x="7955279" y="1188720"/>
-            <a:ext cx="3566160" cy="2560320"/>
+            <a:ext cx="3566160" cy="2377440"/>
           </a:xfrm>
           <a:prstGeom prst="roundRect">
             <a:avLst/>
@@ -22294,7 +22180,7 @@
         <p:spPr>
           <a:xfrm>
             <a:off x="8183879" y="1645920"/>
-            <a:ext cx="3108960" cy="2011679"/>
+            <a:ext cx="3108960" cy="1828800"/>
           </a:xfrm>
           <a:prstGeom prst="rect">
             <a:avLst/>
@@ -22322,7 +22208,7 @@
                 </a:solidFill>
                 <a:latin typeface="Consolas"/>
               </a:rPr>
-              <a:t>❯ Adding new Python challenge...</a:t>
+              <a:t>❯ New Python challenge...</a:t>
             </a:r>
           </a:p>
           <a:p>
@@ -22341,7 +22227,7 @@
                 </a:solidFill>
                 <a:latin typeface="Consolas"/>
               </a:rPr>
-              <a:t>  Analyzing difficulty curve...</a:t>
+              <a:t>  Analyzing difficulty curve</a:t>
             </a:r>
           </a:p>
           <a:p>
@@ -22360,7 +22246,7 @@
                 </a:solidFill>
                 <a:latin typeface="Consolas"/>
               </a:rPr>
-              <a:t>  → Level 15: async/await basics</a:t>
+              <a:t>  → Level 15: async/await</a:t>
             </a:r>
           </a:p>
           <a:p>
@@ -22379,7 +22265,7 @@
                 </a:solidFill>
                 <a:latin typeface="Consolas"/>
               </a:rPr>
-              <a:t>  ✓ Challenge generated + tested</a:t>
+              <a:t>  ✓ Challenge generated</a:t>
             </a:r>
           </a:p>
         </p:txBody>
@@ -22392,7 +22278,7 @@
         </p:nvSpPr>
         <p:spPr>
           <a:xfrm>
-            <a:off x="457200" y="4023360"/>
+            <a:off x="457200" y="3840480"/>
             <a:ext cx="11155680" cy="1371600"/>
           </a:xfrm>
           <a:prstGeom prst="roundRect">
@@ -22437,7 +22323,7 @@
         </p:nvSpPr>
         <p:spPr>
           <a:xfrm>
-            <a:off x="457200" y="4023360"/>
+            <a:off x="457200" y="3840480"/>
             <a:ext cx="11155680" cy="365760"/>
           </a:xfrm>
           <a:prstGeom prst="rect">
@@ -22480,7 +22366,7 @@
         </p:nvSpPr>
         <p:spPr>
           <a:xfrm>
-            <a:off x="640080" y="4142232"/>
+            <a:off x="640080" y="3959352"/>
             <a:ext cx="128016" cy="128016"/>
           </a:xfrm>
           <a:prstGeom prst="ellipse">
@@ -22523,7 +22409,7 @@
         </p:nvSpPr>
         <p:spPr>
           <a:xfrm>
-            <a:off x="868680" y="4142232"/>
+            <a:off x="868680" y="3959352"/>
             <a:ext cx="128016" cy="128016"/>
           </a:xfrm>
           <a:prstGeom prst="ellipse">
@@ -22566,7 +22452,7 @@
         </p:nvSpPr>
         <p:spPr>
           <a:xfrm>
-            <a:off x="1097280" y="4142232"/>
+            <a:off x="1097280" y="3959352"/>
             <a:ext cx="128016" cy="128016"/>
           </a:xfrm>
           <a:prstGeom prst="ellipse">
@@ -22609,7 +22495,7 @@
         </p:nvSpPr>
         <p:spPr>
           <a:xfrm>
-            <a:off x="1371600" y="4069080"/>
+            <a:off x="1371600" y="3886200"/>
             <a:ext cx="10058400" cy="320040"/>
           </a:xfrm>
           <a:prstGeom prst="rect">
@@ -22649,7 +22535,7 @@
         </p:nvSpPr>
         <p:spPr>
           <a:xfrm>
-            <a:off x="685800" y="4480560"/>
+            <a:off x="685800" y="4297680"/>
             <a:ext cx="10698480" cy="822960"/>
           </a:xfrm>
           <a:prstGeom prst="rect">
@@ -22678,7 +22564,7 @@
                 </a:solidFill>
                 <a:latin typeface="Consolas"/>
               </a:rPr>
-              <a:t>❯ Agent Teams active: 3 teammates working across 3 projects</a:t>
+              <a:t>❯ Agent Teams: 3 teammates across 3 projects</a:t>
             </a:r>
           </a:p>
           <a:p>
@@ -22697,7 +22583,7 @@
                 </a:solidFill>
                 <a:latin typeface="Consolas"/>
               </a:rPr>
-              <a:t>  Cortis: auth fix in progress  |  Broadside: new integration  |  Zeroshot: content</a:t>
+              <a:t>  Cortis: auth fix  |  Broadside: TikTok  |  Zeroshot: content</a:t>
             </a:r>
           </a:p>
         </p:txBody>
@@ -25296,7 +25182,7 @@
         <p:spPr>
           <a:xfrm>
             <a:off x="457200" y="1371600"/>
-            <a:ext cx="11247120" cy="5029200"/>
+            <a:ext cx="11247120" cy="4754880"/>
           </a:xfrm>
           <a:prstGeom prst="roundRect">
             <a:avLst/>
@@ -25553,7 +25439,7 @@
         <p:spPr>
           <a:xfrm>
             <a:off x="685800" y="1828800"/>
-            <a:ext cx="10789920" cy="4480560"/>
+            <a:ext cx="10789920" cy="4206240"/>
           </a:xfrm>
           <a:prstGeom prst="rect">
             <a:avLst/>
@@ -25619,7 +25505,7 @@
                 </a:solidFill>
                 <a:latin typeface="Consolas"/>
               </a:rPr>
-              <a:t># Claude explores the repo structure...</a:t>
+              <a:t># Claude explores the repo...</a:t>
             </a:r>
           </a:p>
           <a:p>
@@ -25657,7 +25543,7 @@
                 </a:solidFill>
                 <a:latin typeface="Consolas"/>
               </a:rPr>
-              <a:t>  Checking for conflicts with existing commands...</a:t>
+              <a:t>  Checking for conflicts...</a:t>
             </a:r>
           </a:p>
           <a:p>
@@ -25695,7 +25581,7 @@
                 </a:solidFill>
                 <a:latin typeface="Consolas"/>
               </a:rPr>
-              <a:t># Found conflict: /ship and /retro already exist</a:t>
+              <a:t># Found conflict: /ship and /retro exist</a:t>
             </a:r>
           </a:p>
           <a:p>
@@ -25714,7 +25600,7 @@
                 </a:solidFill>
                 <a:latin typeface="Consolas"/>
               </a:rPr>
-              <a:t>  → Suggesting --prefix mode (gstack- prefix)</a:t>
+              <a:t>  → Using --prefix mode (gstack- prefix)</a:t>
             </a:r>
           </a:p>
           <a:p>
@@ -25771,7 +25657,7 @@
                 </a:solidFill>
                 <a:latin typeface="Consolas"/>
               </a:rPr>
-              <a:t>  → Installing Bun (missing dependency)</a:t>
+              <a:t>  → Installing Bun + updating config</a:t>
             </a:r>
           </a:p>
           <a:p>
@@ -25786,11 +25672,11 @@
             <a:r>
               <a:rPr sz="1200">
                 <a:solidFill>
-                  <a:srgbClr val="89B4FA"/>
+                  <a:srgbClr val="CDD6F4"/>
                 </a:solidFill>
                 <a:latin typeface="Consolas"/>
               </a:rPr>
-              <a:t>  → Updating ~/.claude/settings.json</a:t>
+              <a:t/>
             </a:r>
           </a:p>
           <a:p>
@@ -25805,6 +25691,63 @@
             <a:r>
               <a:rPr sz="1200">
                 <a:solidFill>
+                  <a:srgbClr val="A6ADC8"/>
+                </a:solidFill>
+                <a:latin typeface="Consolas"/>
+              </a:rPr>
+              <a:t>  linked: gstack-autoplan gstack-review</a:t>
+            </a:r>
+          </a:p>
+          <a:p>
+            <a:pPr>
+              <a:spcBef>
+                <a:spcPts val="200"/>
+              </a:spcBef>
+              <a:spcAft>
+                <a:spcPts val="0"/>
+              </a:spcAft>
+            </a:pPr>
+            <a:r>
+              <a:rPr sz="1200">
+                <a:solidFill>
+                  <a:srgbClr val="A6ADC8"/>
+                </a:solidFill>
+                <a:latin typeface="Consolas"/>
+              </a:rPr>
+              <a:t>    gstack-ship gstack-qa gstack-cso</a:t>
+            </a:r>
+          </a:p>
+          <a:p>
+            <a:pPr>
+              <a:spcBef>
+                <a:spcPts val="200"/>
+              </a:spcBef>
+              <a:spcAft>
+                <a:spcPts val="0"/>
+              </a:spcAft>
+            </a:pPr>
+            <a:r>
+              <a:rPr sz="1200">
+                <a:solidFill>
+                  <a:srgbClr val="A6ADC8"/>
+                </a:solidFill>
+                <a:latin typeface="Consolas"/>
+              </a:rPr>
+              <a:t>    gstack-investigate ... (36 total)</a:t>
+            </a:r>
+          </a:p>
+          <a:p>
+            <a:pPr>
+              <a:spcBef>
+                <a:spcPts val="200"/>
+              </a:spcBef>
+              <a:spcAft>
+                <a:spcPts val="0"/>
+              </a:spcAft>
+            </a:pPr>
+            <a:r>
+              <a:rPr sz="1200">
+                <a:solidFill>
                   <a:srgbClr val="CDD6F4"/>
                 </a:solidFill>
                 <a:latin typeface="Consolas"/>
@@ -25824,144 +25767,11 @@
             <a:r>
               <a:rPr sz="1200">
                 <a:solidFill>
-                  <a:srgbClr val="A6ADC8"/>
+                  <a:srgbClr val="A6E3A1"/>
                 </a:solidFill>
                 <a:latin typeface="Consolas"/>
               </a:rPr>
-              <a:t>  linked: gstack-autoplan gstack-benchmark</a:t>
-            </a:r>
-          </a:p>
-          <a:p>
-            <a:pPr>
-              <a:spcBef>
-                <a:spcPts val="200"/>
-              </a:spcBef>
-              <a:spcAft>
-                <a:spcPts val="0"/>
-              </a:spcAft>
-            </a:pPr>
-            <a:r>
-              <a:rPr sz="1200">
-                <a:solidFill>
-                  <a:srgbClr val="A6ADC8"/>
-                </a:solidFill>
-                <a:latin typeface="Consolas"/>
-              </a:rPr>
-              <a:t>          gstack-browse gstack-canary gstack-careful</a:t>
-            </a:r>
-          </a:p>
-          <a:p>
-            <a:pPr>
-              <a:spcBef>
-                <a:spcPts val="200"/>
-              </a:spcBef>
-              <a:spcAft>
-                <a:spcPts val="0"/>
-              </a:spcAft>
-            </a:pPr>
-            <a:r>
-              <a:rPr sz="1200">
-                <a:solidFill>
-                  <a:srgbClr val="A6ADC8"/>
-                </a:solidFill>
-                <a:latin typeface="Consolas"/>
-              </a:rPr>
-              <a:t>          gstack-checkpoint gstack-codex gstack-cso</a:t>
-            </a:r>
-          </a:p>
-          <a:p>
-            <a:pPr>
-              <a:spcBef>
-                <a:spcPts val="200"/>
-              </a:spcBef>
-              <a:spcAft>
-                <a:spcPts val="0"/>
-              </a:spcAft>
-            </a:pPr>
-            <a:r>
-              <a:rPr sz="1200">
-                <a:solidFill>
-                  <a:srgbClr val="A6ADC8"/>
-                </a:solidFill>
-                <a:latin typeface="Consolas"/>
-              </a:rPr>
-              <a:t>          gstack-freeze gstack-guard gstack-investigate</a:t>
-            </a:r>
-          </a:p>
-          <a:p>
-            <a:pPr>
-              <a:spcBef>
-                <a:spcPts val="200"/>
-              </a:spcBef>
-              <a:spcAft>
-                <a:spcPts val="0"/>
-              </a:spcAft>
-            </a:pPr>
-            <a:r>
-              <a:rPr sz="1200">
-                <a:solidFill>
-                  <a:srgbClr val="A6ADC8"/>
-                </a:solidFill>
-                <a:latin typeface="Consolas"/>
-              </a:rPr>
-              <a:t>          gstack-office-hours gstack-qa gstack-review</a:t>
-            </a:r>
-          </a:p>
-          <a:p>
-            <a:pPr>
-              <a:spcBef>
-                <a:spcPts val="200"/>
-              </a:spcBef>
-              <a:spcAft>
-                <a:spcPts val="0"/>
-              </a:spcAft>
-            </a:pPr>
-            <a:r>
-              <a:rPr sz="1200">
-                <a:solidFill>
-                  <a:srgbClr val="A6ADC8"/>
-                </a:solidFill>
-                <a:latin typeface="Consolas"/>
-              </a:rPr>
-              <a:t>          gstack-retro gstack-ship ... (36 total)</a:t>
-            </a:r>
-          </a:p>
-          <a:p>
-            <a:pPr>
-              <a:spcBef>
-                <a:spcPts val="200"/>
-              </a:spcBef>
-              <a:spcAft>
-                <a:spcPts val="0"/>
-              </a:spcAft>
-            </a:pPr>
-            <a:r>
-              <a:rPr sz="1200">
-                <a:solidFill>
-                  <a:srgbClr val="CDD6F4"/>
-                </a:solidFill>
-                <a:latin typeface="Consolas"/>
-              </a:rPr>
-              <a:t/>
-            </a:r>
-          </a:p>
-          <a:p>
-            <a:pPr>
-              <a:spcBef>
-                <a:spcPts val="200"/>
-              </a:spcBef>
-              <a:spcAft>
-                <a:spcPts val="0"/>
-              </a:spcAft>
-            </a:pPr>
-            <a:r>
-              <a:rPr sz="1200">
-                <a:solidFill>
-                  <a:srgbClr val="A6E3A1"/>
-                </a:solidFill>
-                <a:latin typeface="Consolas"/>
-              </a:rPr>
-              <a:t>  ✓ gstack ready. All 36 skills available globally.</a:t>
+              <a:t>  ✓ gstack ready. 36 skills available.</a:t>
             </a:r>
           </a:p>
         </p:txBody>

</xml_diff>